<commit_message>
Add Lesson 4 materials: PED revenue & significance (2.6.4-2.6.5)
Expanded format per tutor request: 16-slide interactive deck with
guess-then-reveal worked examples (reusing Lesson 3's PED figures,
extended with revenue calculations), a live fill-in-the-blank guided
practice slide, and a comprehensive slide-by-slide teaching script
(talking points, anticipated student questions, comprehension-check
questions with model answers) rather than a brief outline. Also weaves
in two targeted correctives (land vs free goods; causes vs consequences
of price changes) identified from the student's actual Lesson 2
worksheet. Adds reusable pptx helpers: tagPill, ruleTableSlide,
blankCalcSlide, and a tag/color-aware calcSlide variant.
</commit_message>
<xml_diff>
--- a/courses/tom-economics/lessons/lesson-03/slides.pptx
+++ b/courses/tom-economics/lessons/lesson-03/slides.pptx
@@ -2621,12 +2621,12 @@
         </p:nvSpPr>
         <p:spPr>
           <a:xfrm>
-            <a:off x="3566160" y="1645920"/>
-            <a:ext cx="5029200" cy="3291840"/>
+            <a:off x="3566160" y="1920240"/>
+            <a:ext cx="5029200" cy="3108960"/>
           </a:xfrm>
           <a:prstGeom prst="roundRect">
             <a:avLst>
-              <a:gd name="adj" fmla="val 3889"/>
+              <a:gd name="adj" fmla="val 4118"/>
             </a:avLst>
           </a:prstGeom>
           <a:solidFill>
@@ -2643,7 +2643,7 @@
         </p:nvSpPr>
         <p:spPr>
           <a:xfrm>
-            <a:off x="3840480" y="1920240"/>
+            <a:off x="3840480" y="2194560"/>
             <a:ext cx="4480560" cy="365760"/>
           </a:xfrm>
           <a:prstGeom prst="rect">
@@ -2682,7 +2682,7 @@
         </p:nvSpPr>
         <p:spPr>
           <a:xfrm>
-            <a:off x="3840480" y="2377440"/>
+            <a:off x="3840480" y="2651760"/>
             <a:ext cx="4480560" cy="1463040"/>
           </a:xfrm>
           <a:prstGeom prst="rect">
@@ -2744,8 +2744,8 @@
         </p:nvSpPr>
         <p:spPr>
           <a:xfrm>
-            <a:off x="3840480" y="3931920"/>
-            <a:ext cx="4480560" cy="822960"/>
+            <a:off x="3840480" y="4206240"/>
+            <a:ext cx="4480560" cy="731520"/>
           </a:xfrm>
           <a:prstGeom prst="rect">
             <a:avLst/>
@@ -2761,7 +2761,7 @@
               <a:buNone/>
             </a:pPr>
             <a:r>
-              <a:rPr lang="en-US" sz="2000" b="1" dirty="0">
+              <a:rPr lang="en-US" sz="1800" b="1" dirty="0">
                 <a:solidFill>
                   <a:srgbClr val="1E2761"/>
                 </a:solidFill>
@@ -2771,7 +2771,7 @@
               </a:rPr>
               <a:t>PED = −20 ÷ 10 = −2 → Elastic</a:t>
             </a:r>
-            <a:endParaRPr lang="en-US" sz="2000" dirty="0"/>
+            <a:endParaRPr lang="en-US" sz="1800" dirty="0"/>
           </a:p>
         </p:txBody>
       </p:sp>
@@ -2854,12 +2854,12 @@
         </p:nvSpPr>
         <p:spPr>
           <a:xfrm>
-            <a:off x="3566160" y="1645920"/>
-            <a:ext cx="5029200" cy="3291840"/>
+            <a:off x="3566160" y="1920240"/>
+            <a:ext cx="5029200" cy="3108960"/>
           </a:xfrm>
           <a:prstGeom prst="roundRect">
             <a:avLst>
-              <a:gd name="adj" fmla="val 3889"/>
+              <a:gd name="adj" fmla="val 4118"/>
             </a:avLst>
           </a:prstGeom>
           <a:solidFill>
@@ -2876,7 +2876,7 @@
         </p:nvSpPr>
         <p:spPr>
           <a:xfrm>
-            <a:off x="3840480" y="1920240"/>
+            <a:off x="3840480" y="2194560"/>
             <a:ext cx="4480560" cy="365760"/>
           </a:xfrm>
           <a:prstGeom prst="rect">
@@ -2915,7 +2915,7 @@
         </p:nvSpPr>
         <p:spPr>
           <a:xfrm>
-            <a:off x="3840480" y="2377440"/>
+            <a:off x="3840480" y="2651760"/>
             <a:ext cx="4480560" cy="1463040"/>
           </a:xfrm>
           <a:prstGeom prst="rect">
@@ -2977,8 +2977,8 @@
         </p:nvSpPr>
         <p:spPr>
           <a:xfrm>
-            <a:off x="3840480" y="3931920"/>
-            <a:ext cx="4480560" cy="822960"/>
+            <a:off x="3840480" y="4206240"/>
+            <a:ext cx="4480560" cy="731520"/>
           </a:xfrm>
           <a:prstGeom prst="rect">
             <a:avLst/>
@@ -2994,7 +2994,7 @@
               <a:buNone/>
             </a:pPr>
             <a:r>
-              <a:rPr lang="en-US" sz="2000" b="1" dirty="0">
+              <a:rPr lang="en-US" sz="1800" b="1" dirty="0">
                 <a:solidFill>
                   <a:srgbClr val="1E2761"/>
                 </a:solidFill>
@@ -3004,7 +3004,7 @@
               </a:rPr>
               <a:t>PED = −5 ÷ 10 = −0.5 → Inelastic</a:t>
             </a:r>
-            <a:endParaRPr lang="en-US" sz="2000" dirty="0"/>
+            <a:endParaRPr lang="en-US" sz="1800" dirty="0"/>
           </a:p>
         </p:txBody>
       </p:sp>

</xml_diff>